<commit_message>
Updates for release 1.29.0 (OU)
</commit_message>
<xml_diff>
--- a/etc/diagrams.pptx
+++ b/etc/diagrams.pptx
@@ -6,6 +6,10 @@
   </p:sldMasterIdLst>
   <p:sldIdLst>
     <p:sldId id="258" r:id="rId2"/>
+    <p:sldId id="259" r:id="rId3"/>
+    <p:sldId id="262" r:id="rId4"/>
+    <p:sldId id="261" r:id="rId5"/>
+    <p:sldId id="263" r:id="rId6"/>
   </p:sldIdLst>
   <p:sldSz cx="12192000" cy="6858000"/>
   <p:notesSz cx="6858000" cy="9144000"/>
@@ -104,6 +108,11 @@
       </a:defRPr>
     </a:lvl9pPr>
   </p:defaultTextStyle>
+  <p:extLst>
+    <p:ext uri="{EFAFB233-063F-42B5-8137-9DF3F51BA10A}">
+      <p15:sldGuideLst xmlns:p15="http://schemas.microsoft.com/office/powerpoint/2012/main"/>
+    </p:ext>
+  </p:extLst>
 </p:presentation>
 </file>
 
@@ -256,7 +265,7 @@
           <a:p>
             <a:fld id="{6DE958AC-4A11-4132-8728-A1A7D4D6776D}" type="datetimeFigureOut">
               <a:rPr lang="en-GB" smtClean="0"/>
-              <a:t>11/06/2018</a:t>
+              <a:t>18/03/2026</a:t>
             </a:fld>
             <a:endParaRPr lang="en-GB"/>
           </a:p>
@@ -456,7 +465,7 @@
           <a:p>
             <a:fld id="{6DE958AC-4A11-4132-8728-A1A7D4D6776D}" type="datetimeFigureOut">
               <a:rPr lang="en-GB" smtClean="0"/>
-              <a:t>11/06/2018</a:t>
+              <a:t>18/03/2026</a:t>
             </a:fld>
             <a:endParaRPr lang="en-GB"/>
           </a:p>
@@ -666,7 +675,7 @@
           <a:p>
             <a:fld id="{6DE958AC-4A11-4132-8728-A1A7D4D6776D}" type="datetimeFigureOut">
               <a:rPr lang="en-GB" smtClean="0"/>
-              <a:t>11/06/2018</a:t>
+              <a:t>18/03/2026</a:t>
             </a:fld>
             <a:endParaRPr lang="en-GB"/>
           </a:p>
@@ -866,7 +875,7 @@
           <a:p>
             <a:fld id="{6DE958AC-4A11-4132-8728-A1A7D4D6776D}" type="datetimeFigureOut">
               <a:rPr lang="en-GB" smtClean="0"/>
-              <a:t>11/06/2018</a:t>
+              <a:t>18/03/2026</a:t>
             </a:fld>
             <a:endParaRPr lang="en-GB"/>
           </a:p>
@@ -1142,7 +1151,7 @@
           <a:p>
             <a:fld id="{6DE958AC-4A11-4132-8728-A1A7D4D6776D}" type="datetimeFigureOut">
               <a:rPr lang="en-GB" smtClean="0"/>
-              <a:t>11/06/2018</a:t>
+              <a:t>18/03/2026</a:t>
             </a:fld>
             <a:endParaRPr lang="en-GB"/>
           </a:p>
@@ -1410,7 +1419,7 @@
           <a:p>
             <a:fld id="{6DE958AC-4A11-4132-8728-A1A7D4D6776D}" type="datetimeFigureOut">
               <a:rPr lang="en-GB" smtClean="0"/>
-              <a:t>11/06/2018</a:t>
+              <a:t>18/03/2026</a:t>
             </a:fld>
             <a:endParaRPr lang="en-GB"/>
           </a:p>
@@ -1825,7 +1834,7 @@
           <a:p>
             <a:fld id="{6DE958AC-4A11-4132-8728-A1A7D4D6776D}" type="datetimeFigureOut">
               <a:rPr lang="en-GB" smtClean="0"/>
-              <a:t>11/06/2018</a:t>
+              <a:t>18/03/2026</a:t>
             </a:fld>
             <a:endParaRPr lang="en-GB"/>
           </a:p>
@@ -1967,7 +1976,7 @@
           <a:p>
             <a:fld id="{6DE958AC-4A11-4132-8728-A1A7D4D6776D}" type="datetimeFigureOut">
               <a:rPr lang="en-GB" smtClean="0"/>
-              <a:t>11/06/2018</a:t>
+              <a:t>18/03/2026</a:t>
             </a:fld>
             <a:endParaRPr lang="en-GB"/>
           </a:p>
@@ -2080,7 +2089,7 @@
           <a:p>
             <a:fld id="{6DE958AC-4A11-4132-8728-A1A7D4D6776D}" type="datetimeFigureOut">
               <a:rPr lang="en-GB" smtClean="0"/>
-              <a:t>11/06/2018</a:t>
+              <a:t>18/03/2026</a:t>
             </a:fld>
             <a:endParaRPr lang="en-GB"/>
           </a:p>
@@ -2393,7 +2402,7 @@
           <a:p>
             <a:fld id="{6DE958AC-4A11-4132-8728-A1A7D4D6776D}" type="datetimeFigureOut">
               <a:rPr lang="en-GB" smtClean="0"/>
-              <a:t>11/06/2018</a:t>
+              <a:t>18/03/2026</a:t>
             </a:fld>
             <a:endParaRPr lang="en-GB"/>
           </a:p>
@@ -2682,7 +2691,7 @@
           <a:p>
             <a:fld id="{6DE958AC-4A11-4132-8728-A1A7D4D6776D}" type="datetimeFigureOut">
               <a:rPr lang="en-GB" smtClean="0"/>
-              <a:t>11/06/2018</a:t>
+              <a:t>18/03/2026</a:t>
             </a:fld>
             <a:endParaRPr lang="en-GB"/>
           </a:p>
@@ -2925,7 +2934,7 @@
           <a:p>
             <a:fld id="{6DE958AC-4A11-4132-8728-A1A7D4D6776D}" type="datetimeFigureOut">
               <a:rPr lang="en-GB" smtClean="0"/>
-              <a:t>11/06/2018</a:t>
+              <a:t>18/03/2026</a:t>
             </a:fld>
             <a:endParaRPr lang="en-GB"/>
           </a:p>
@@ -4559,6 +4568,745 @@
 </p:sld>
 </file>
 
+<file path=ppt/slides/slide2.xml><?xml version="1.0" encoding="utf-8"?>
+<p:sld xmlns:a="http://schemas.openxmlformats.org/drawingml/2006/main" xmlns:r="http://schemas.openxmlformats.org/officeDocument/2006/relationships" xmlns:p="http://schemas.openxmlformats.org/presentationml/2006/main">
+  <p:cSld>
+    <p:spTree>
+      <p:nvGrpSpPr>
+        <p:cNvPr id="1" name=""/>
+        <p:cNvGrpSpPr/>
+        <p:nvPr/>
+      </p:nvGrpSpPr>
+      <p:grpSpPr>
+        <a:xfrm>
+          <a:off x="0" y="0"/>
+          <a:ext cx="0" cy="0"/>
+          <a:chOff x="0" y="0"/>
+          <a:chExt cx="0" cy="0"/>
+        </a:xfrm>
+      </p:grpSpPr>
+      <p:grpSp>
+        <p:nvGrpSpPr>
+          <p:cNvPr id="11" name="Group 10">
+            <a:extLst>
+              <a:ext uri="{FF2B5EF4-FFF2-40B4-BE49-F238E27FC236}">
+                <a16:creationId xmlns:a16="http://schemas.microsoft.com/office/drawing/2014/main" id="{06876790-E4DC-80E6-C926-8520FAE9E722}"/>
+              </a:ext>
+            </a:extLst>
+          </p:cNvPr>
+          <p:cNvGrpSpPr/>
+          <p:nvPr/>
+        </p:nvGrpSpPr>
+        <p:grpSpPr>
+          <a:xfrm>
+            <a:off x="270649" y="799733"/>
+            <a:ext cx="11650701" cy="5258534"/>
+            <a:chOff x="270649" y="799733"/>
+            <a:chExt cx="11650701" cy="5258534"/>
+          </a:xfrm>
+        </p:grpSpPr>
+        <p:pic>
+          <p:nvPicPr>
+            <p:cNvPr id="5" name="Picture 4">
+              <a:extLst>
+                <a:ext uri="{FF2B5EF4-FFF2-40B4-BE49-F238E27FC236}">
+                  <a16:creationId xmlns:a16="http://schemas.microsoft.com/office/drawing/2014/main" id="{D141D8D0-90A2-97BE-F5CB-F44ABDD06676}"/>
+                </a:ext>
+              </a:extLst>
+            </p:cNvPr>
+            <p:cNvPicPr>
+              <a:picLocks noChangeAspect="1"/>
+            </p:cNvPicPr>
+            <p:nvPr/>
+          </p:nvPicPr>
+          <p:blipFill>
+            <a:blip r:embed="rId2"/>
+            <a:stretch>
+              <a:fillRect/>
+            </a:stretch>
+          </p:blipFill>
+          <p:spPr>
+            <a:xfrm>
+              <a:off x="270649" y="799733"/>
+              <a:ext cx="11650701" cy="5258534"/>
+            </a:xfrm>
+            <a:prstGeom prst="rect">
+              <a:avLst/>
+            </a:prstGeom>
+          </p:spPr>
+        </p:pic>
+        <p:sp>
+          <p:nvSpPr>
+            <p:cNvPr id="6" name="Rectangle: Rounded Corners 5">
+              <a:extLst>
+                <a:ext uri="{FF2B5EF4-FFF2-40B4-BE49-F238E27FC236}">
+                  <a16:creationId xmlns:a16="http://schemas.microsoft.com/office/drawing/2014/main" id="{E3EDC6E9-7E13-71A8-628F-919083B40397}"/>
+                </a:ext>
+              </a:extLst>
+            </p:cNvPr>
+            <p:cNvSpPr/>
+            <p:nvPr/>
+          </p:nvSpPr>
+          <p:spPr>
+            <a:xfrm>
+              <a:off x="626865" y="3056101"/>
+              <a:ext cx="1782848" cy="870440"/>
+            </a:xfrm>
+            <a:prstGeom prst="roundRect">
+              <a:avLst/>
+            </a:prstGeom>
+            <a:noFill/>
+            <a:ln w="25400">
+              <a:solidFill>
+                <a:srgbClr val="C00000"/>
+              </a:solidFill>
+            </a:ln>
+            <a:effectLst>
+              <a:outerShdw blurRad="50800" dist="38100" dir="2700000" algn="tl" rotWithShape="0">
+                <a:prstClr val="black">
+                  <a:alpha val="40000"/>
+                </a:prstClr>
+              </a:outerShdw>
+            </a:effectLst>
+          </p:spPr>
+          <p:style>
+            <a:lnRef idx="2">
+              <a:schemeClr val="accent1">
+                <a:shade val="15000"/>
+              </a:schemeClr>
+            </a:lnRef>
+            <a:fillRef idx="1">
+              <a:schemeClr val="accent1"/>
+            </a:fillRef>
+            <a:effectRef idx="0">
+              <a:schemeClr val="accent1"/>
+            </a:effectRef>
+            <a:fontRef idx="minor">
+              <a:schemeClr val="lt1"/>
+            </a:fontRef>
+          </p:style>
+          <p:txBody>
+            <a:bodyPr rtlCol="0" anchor="ctr"/>
+            <a:lstStyle/>
+            <a:p>
+              <a:pPr algn="ctr"/>
+              <a:endParaRPr lang="en-GB"/>
+            </a:p>
+          </p:txBody>
+        </p:sp>
+        <p:sp>
+          <p:nvSpPr>
+            <p:cNvPr id="10" name="Arrow: Right 9">
+              <a:extLst>
+                <a:ext uri="{FF2B5EF4-FFF2-40B4-BE49-F238E27FC236}">
+                  <a16:creationId xmlns:a16="http://schemas.microsoft.com/office/drawing/2014/main" id="{5A2E1480-BF37-4ED1-AE3C-590A637F7D91}"/>
+                </a:ext>
+              </a:extLst>
+            </p:cNvPr>
+            <p:cNvSpPr/>
+            <p:nvPr/>
+          </p:nvSpPr>
+          <p:spPr>
+            <a:xfrm rot="8441955">
+              <a:off x="2329549" y="2571077"/>
+              <a:ext cx="978408" cy="334025"/>
+            </a:xfrm>
+            <a:prstGeom prst="rightArrow">
+              <a:avLst/>
+            </a:prstGeom>
+            <a:solidFill>
+              <a:srgbClr val="C00000"/>
+            </a:solidFill>
+            <a:ln>
+              <a:noFill/>
+            </a:ln>
+            <a:effectLst>
+              <a:outerShdw blurRad="50800" dist="38100" dir="2700000" algn="tl" rotWithShape="0">
+                <a:prstClr val="black">
+                  <a:alpha val="40000"/>
+                </a:prstClr>
+              </a:outerShdw>
+            </a:effectLst>
+          </p:spPr>
+          <p:style>
+            <a:lnRef idx="2">
+              <a:schemeClr val="accent1">
+                <a:shade val="15000"/>
+              </a:schemeClr>
+            </a:lnRef>
+            <a:fillRef idx="1">
+              <a:schemeClr val="accent1"/>
+            </a:fillRef>
+            <a:effectRef idx="0">
+              <a:schemeClr val="accent1"/>
+            </a:effectRef>
+            <a:fontRef idx="minor">
+              <a:schemeClr val="lt1"/>
+            </a:fontRef>
+          </p:style>
+          <p:txBody>
+            <a:bodyPr rtlCol="0" anchor="ctr"/>
+            <a:lstStyle/>
+            <a:p>
+              <a:pPr algn="ctr"/>
+              <a:endParaRPr lang="en-GB"/>
+            </a:p>
+          </p:txBody>
+        </p:sp>
+      </p:grpSp>
+    </p:spTree>
+    <p:extLst>
+      <p:ext uri="{BB962C8B-B14F-4D97-AF65-F5344CB8AC3E}">
+        <p14:creationId xmlns:p14="http://schemas.microsoft.com/office/powerpoint/2010/main" val="2429021413"/>
+      </p:ext>
+    </p:extLst>
+  </p:cSld>
+  <p:clrMapOvr>
+    <a:masterClrMapping/>
+  </p:clrMapOvr>
+</p:sld>
+</file>
+
+<file path=ppt/slides/slide3.xml><?xml version="1.0" encoding="utf-8"?>
+<p:sld xmlns:a="http://schemas.openxmlformats.org/drawingml/2006/main" xmlns:r="http://schemas.openxmlformats.org/officeDocument/2006/relationships" xmlns:p="http://schemas.openxmlformats.org/presentationml/2006/main">
+  <p:cSld>
+    <p:spTree>
+      <p:nvGrpSpPr>
+        <p:cNvPr id="1" name=""/>
+        <p:cNvGrpSpPr/>
+        <p:nvPr/>
+      </p:nvGrpSpPr>
+      <p:grpSpPr>
+        <a:xfrm>
+          <a:off x="0" y="0"/>
+          <a:ext cx="0" cy="0"/>
+          <a:chOff x="0" y="0"/>
+          <a:chExt cx="0" cy="0"/>
+        </a:xfrm>
+      </p:grpSpPr>
+      <p:pic>
+        <p:nvPicPr>
+          <p:cNvPr id="5" name="Picture 4">
+            <a:extLst>
+              <a:ext uri="{FF2B5EF4-FFF2-40B4-BE49-F238E27FC236}">
+                <a16:creationId xmlns:a16="http://schemas.microsoft.com/office/drawing/2014/main" id="{43DCDF08-5308-0DB4-66F8-9C7519874183}"/>
+              </a:ext>
+            </a:extLst>
+          </p:cNvPr>
+          <p:cNvPicPr>
+            <a:picLocks noChangeAspect="1"/>
+          </p:cNvPicPr>
+          <p:nvPr/>
+        </p:nvPicPr>
+        <p:blipFill>
+          <a:blip r:embed="rId2"/>
+          <a:stretch>
+            <a:fillRect/>
+          </a:stretch>
+        </p:blipFill>
+        <p:spPr>
+          <a:xfrm>
+            <a:off x="732676" y="2800262"/>
+            <a:ext cx="10726647" cy="1257475"/>
+          </a:xfrm>
+          <a:prstGeom prst="rect">
+            <a:avLst/>
+          </a:prstGeom>
+        </p:spPr>
+      </p:pic>
+      <p:sp>
+        <p:nvSpPr>
+          <p:cNvPr id="6" name="Rectangle: Rounded Corners 5">
+            <a:extLst>
+              <a:ext uri="{FF2B5EF4-FFF2-40B4-BE49-F238E27FC236}">
+                <a16:creationId xmlns:a16="http://schemas.microsoft.com/office/drawing/2014/main" id="{F2277689-2D14-6F32-6B44-0F1DB8502154}"/>
+              </a:ext>
+            </a:extLst>
+          </p:cNvPr>
+          <p:cNvSpPr/>
+          <p:nvPr/>
+        </p:nvSpPr>
+        <p:spPr>
+          <a:xfrm>
+            <a:off x="9042400" y="2978150"/>
+            <a:ext cx="967750" cy="289169"/>
+          </a:xfrm>
+          <a:prstGeom prst="roundRect">
+            <a:avLst/>
+          </a:prstGeom>
+          <a:noFill/>
+          <a:ln w="25400">
+            <a:solidFill>
+              <a:srgbClr val="C00000"/>
+            </a:solidFill>
+          </a:ln>
+          <a:effectLst>
+            <a:outerShdw blurRad="50800" dist="38100" dir="2700000" algn="tl" rotWithShape="0">
+              <a:prstClr val="black">
+                <a:alpha val="40000"/>
+              </a:prstClr>
+            </a:outerShdw>
+          </a:effectLst>
+        </p:spPr>
+        <p:style>
+          <a:lnRef idx="2">
+            <a:schemeClr val="accent1">
+              <a:shade val="15000"/>
+            </a:schemeClr>
+          </a:lnRef>
+          <a:fillRef idx="1">
+            <a:schemeClr val="accent1"/>
+          </a:fillRef>
+          <a:effectRef idx="0">
+            <a:schemeClr val="accent1"/>
+          </a:effectRef>
+          <a:fontRef idx="minor">
+            <a:schemeClr val="lt1"/>
+          </a:fontRef>
+        </p:style>
+        <p:txBody>
+          <a:bodyPr rtlCol="0" anchor="ctr"/>
+          <a:lstStyle/>
+          <a:p>
+            <a:pPr algn="ctr"/>
+            <a:endParaRPr lang="en-GB"/>
+          </a:p>
+        </p:txBody>
+      </p:sp>
+      <p:sp>
+        <p:nvSpPr>
+          <p:cNvPr id="7" name="Arrow: Right 6">
+            <a:extLst>
+              <a:ext uri="{FF2B5EF4-FFF2-40B4-BE49-F238E27FC236}">
+                <a16:creationId xmlns:a16="http://schemas.microsoft.com/office/drawing/2014/main" id="{CADBFAEC-D061-9096-A6ED-24ABD87D2538}"/>
+              </a:ext>
+            </a:extLst>
+          </p:cNvPr>
+          <p:cNvSpPr/>
+          <p:nvPr/>
+        </p:nvSpPr>
+        <p:spPr>
+          <a:xfrm rot="12461655">
+            <a:off x="9985435" y="3355527"/>
+            <a:ext cx="978408" cy="334025"/>
+          </a:xfrm>
+          <a:prstGeom prst="rightArrow">
+            <a:avLst/>
+          </a:prstGeom>
+          <a:solidFill>
+            <a:srgbClr val="C00000"/>
+          </a:solidFill>
+          <a:ln>
+            <a:noFill/>
+          </a:ln>
+          <a:effectLst>
+            <a:outerShdw blurRad="50800" dist="38100" dir="2700000" algn="tl" rotWithShape="0">
+              <a:prstClr val="black">
+                <a:alpha val="40000"/>
+              </a:prstClr>
+            </a:outerShdw>
+          </a:effectLst>
+        </p:spPr>
+        <p:style>
+          <a:lnRef idx="2">
+            <a:schemeClr val="accent1">
+              <a:shade val="15000"/>
+            </a:schemeClr>
+          </a:lnRef>
+          <a:fillRef idx="1">
+            <a:schemeClr val="accent1"/>
+          </a:fillRef>
+          <a:effectRef idx="0">
+            <a:schemeClr val="accent1"/>
+          </a:effectRef>
+          <a:fontRef idx="minor">
+            <a:schemeClr val="lt1"/>
+          </a:fontRef>
+        </p:style>
+        <p:txBody>
+          <a:bodyPr rtlCol="0" anchor="ctr"/>
+          <a:lstStyle/>
+          <a:p>
+            <a:pPr algn="ctr"/>
+            <a:endParaRPr lang="en-GB"/>
+          </a:p>
+        </p:txBody>
+      </p:sp>
+    </p:spTree>
+    <p:extLst>
+      <p:ext uri="{BB962C8B-B14F-4D97-AF65-F5344CB8AC3E}">
+        <p14:creationId xmlns:p14="http://schemas.microsoft.com/office/powerpoint/2010/main" val="619715022"/>
+      </p:ext>
+    </p:extLst>
+  </p:cSld>
+  <p:clrMapOvr>
+    <a:masterClrMapping/>
+  </p:clrMapOvr>
+</p:sld>
+</file>
+
+<file path=ppt/slides/slide4.xml><?xml version="1.0" encoding="utf-8"?>
+<p:sld xmlns:a="http://schemas.openxmlformats.org/drawingml/2006/main" xmlns:r="http://schemas.openxmlformats.org/officeDocument/2006/relationships" xmlns:p="http://schemas.openxmlformats.org/presentationml/2006/main">
+  <p:cSld>
+    <p:spTree>
+      <p:nvGrpSpPr>
+        <p:cNvPr id="1" name="">
+          <a:extLst>
+            <a:ext uri="{FF2B5EF4-FFF2-40B4-BE49-F238E27FC236}">
+              <a16:creationId xmlns:a16="http://schemas.microsoft.com/office/drawing/2014/main" id="{9228CFD7-8F62-9F4B-FD1A-5588E48DE375}"/>
+            </a:ext>
+          </a:extLst>
+        </p:cNvPr>
+        <p:cNvGrpSpPr/>
+        <p:nvPr/>
+      </p:nvGrpSpPr>
+      <p:grpSpPr>
+        <a:xfrm>
+          <a:off x="0" y="0"/>
+          <a:ext cx="0" cy="0"/>
+          <a:chOff x="0" y="0"/>
+          <a:chExt cx="0" cy="0"/>
+        </a:xfrm>
+      </p:grpSpPr>
+      <p:pic>
+        <p:nvPicPr>
+          <p:cNvPr id="3" name="Picture 2">
+            <a:extLst>
+              <a:ext uri="{FF2B5EF4-FFF2-40B4-BE49-F238E27FC236}">
+                <a16:creationId xmlns:a16="http://schemas.microsoft.com/office/drawing/2014/main" id="{F61EED78-0AC5-DFF2-227D-DC2722308FDB}"/>
+              </a:ext>
+            </a:extLst>
+          </p:cNvPr>
+          <p:cNvPicPr>
+            <a:picLocks noChangeAspect="1"/>
+          </p:cNvPicPr>
+          <p:nvPr/>
+        </p:nvPicPr>
+        <p:blipFill>
+          <a:blip r:embed="rId2"/>
+          <a:stretch>
+            <a:fillRect/>
+          </a:stretch>
+        </p:blipFill>
+        <p:spPr>
+          <a:xfrm>
+            <a:off x="270649" y="799733"/>
+            <a:ext cx="11650701" cy="5258534"/>
+          </a:xfrm>
+          <a:prstGeom prst="rect">
+            <a:avLst/>
+          </a:prstGeom>
+        </p:spPr>
+      </p:pic>
+      <p:sp>
+        <p:nvSpPr>
+          <p:cNvPr id="4" name="Rectangle: Rounded Corners 3">
+            <a:extLst>
+              <a:ext uri="{FF2B5EF4-FFF2-40B4-BE49-F238E27FC236}">
+                <a16:creationId xmlns:a16="http://schemas.microsoft.com/office/drawing/2014/main" id="{A94AF337-103E-F1C2-3D9D-8E11A3D9B7A7}"/>
+              </a:ext>
+            </a:extLst>
+          </p:cNvPr>
+          <p:cNvSpPr/>
+          <p:nvPr/>
+        </p:nvSpPr>
+        <p:spPr>
+          <a:xfrm>
+            <a:off x="4103841" y="3522767"/>
+            <a:ext cx="2240513" cy="336039"/>
+          </a:xfrm>
+          <a:prstGeom prst="roundRect">
+            <a:avLst/>
+          </a:prstGeom>
+          <a:noFill/>
+          <a:ln w="25400">
+            <a:solidFill>
+              <a:srgbClr val="C00000"/>
+            </a:solidFill>
+          </a:ln>
+          <a:effectLst>
+            <a:outerShdw blurRad="50800" dist="38100" dir="2700000" algn="tl" rotWithShape="0">
+              <a:prstClr val="black">
+                <a:alpha val="40000"/>
+              </a:prstClr>
+            </a:outerShdw>
+          </a:effectLst>
+        </p:spPr>
+        <p:style>
+          <a:lnRef idx="2">
+            <a:schemeClr val="accent1">
+              <a:shade val="15000"/>
+            </a:schemeClr>
+          </a:lnRef>
+          <a:fillRef idx="1">
+            <a:schemeClr val="accent1"/>
+          </a:fillRef>
+          <a:effectRef idx="0">
+            <a:schemeClr val="accent1"/>
+          </a:effectRef>
+          <a:fontRef idx="minor">
+            <a:schemeClr val="lt1"/>
+          </a:fontRef>
+        </p:style>
+        <p:txBody>
+          <a:bodyPr rtlCol="0" anchor="ctr"/>
+          <a:lstStyle/>
+          <a:p>
+            <a:pPr algn="ctr"/>
+            <a:endParaRPr lang="en-GB"/>
+          </a:p>
+        </p:txBody>
+      </p:sp>
+      <p:sp>
+        <p:nvSpPr>
+          <p:cNvPr id="7" name="Arrow: Right 6">
+            <a:extLst>
+              <a:ext uri="{FF2B5EF4-FFF2-40B4-BE49-F238E27FC236}">
+                <a16:creationId xmlns:a16="http://schemas.microsoft.com/office/drawing/2014/main" id="{A2F11989-A76B-086D-5C33-E3E4E1054E8E}"/>
+              </a:ext>
+            </a:extLst>
+          </p:cNvPr>
+          <p:cNvSpPr/>
+          <p:nvPr/>
+        </p:nvSpPr>
+        <p:spPr>
+          <a:xfrm rot="8441955">
+            <a:off x="6280661" y="2994364"/>
+            <a:ext cx="978408" cy="334025"/>
+          </a:xfrm>
+          <a:prstGeom prst="rightArrow">
+            <a:avLst/>
+          </a:prstGeom>
+          <a:solidFill>
+            <a:srgbClr val="C00000"/>
+          </a:solidFill>
+          <a:ln>
+            <a:noFill/>
+          </a:ln>
+          <a:effectLst>
+            <a:outerShdw blurRad="50800" dist="38100" dir="2700000" algn="tl" rotWithShape="0">
+              <a:prstClr val="black">
+                <a:alpha val="40000"/>
+              </a:prstClr>
+            </a:outerShdw>
+          </a:effectLst>
+        </p:spPr>
+        <p:style>
+          <a:lnRef idx="2">
+            <a:schemeClr val="accent1">
+              <a:shade val="15000"/>
+            </a:schemeClr>
+          </a:lnRef>
+          <a:fillRef idx="1">
+            <a:schemeClr val="accent1"/>
+          </a:fillRef>
+          <a:effectRef idx="0">
+            <a:schemeClr val="accent1"/>
+          </a:effectRef>
+          <a:fontRef idx="minor">
+            <a:schemeClr val="lt1"/>
+          </a:fontRef>
+        </p:style>
+        <p:txBody>
+          <a:bodyPr rtlCol="0" anchor="ctr"/>
+          <a:lstStyle/>
+          <a:p>
+            <a:pPr algn="ctr"/>
+            <a:endParaRPr lang="en-GB"/>
+          </a:p>
+        </p:txBody>
+      </p:sp>
+    </p:spTree>
+    <p:extLst>
+      <p:ext uri="{BB962C8B-B14F-4D97-AF65-F5344CB8AC3E}">
+        <p14:creationId xmlns:p14="http://schemas.microsoft.com/office/powerpoint/2010/main" val="270536781"/>
+      </p:ext>
+    </p:extLst>
+  </p:cSld>
+  <p:clrMapOvr>
+    <a:masterClrMapping/>
+  </p:clrMapOvr>
+</p:sld>
+</file>
+
+<file path=ppt/slides/slide5.xml><?xml version="1.0" encoding="utf-8"?>
+<p:sld xmlns:a="http://schemas.openxmlformats.org/drawingml/2006/main" xmlns:r="http://schemas.openxmlformats.org/officeDocument/2006/relationships" xmlns:p="http://schemas.openxmlformats.org/presentationml/2006/main">
+  <p:cSld>
+    <p:spTree>
+      <p:nvGrpSpPr>
+        <p:cNvPr id="1" name=""/>
+        <p:cNvGrpSpPr/>
+        <p:nvPr/>
+      </p:nvGrpSpPr>
+      <p:grpSpPr>
+        <a:xfrm>
+          <a:off x="0" y="0"/>
+          <a:ext cx="0" cy="0"/>
+          <a:chOff x="0" y="0"/>
+          <a:chExt cx="0" cy="0"/>
+        </a:xfrm>
+      </p:grpSpPr>
+      <p:pic>
+        <p:nvPicPr>
+          <p:cNvPr id="4" name="Picture 3">
+            <a:extLst>
+              <a:ext uri="{FF2B5EF4-FFF2-40B4-BE49-F238E27FC236}">
+                <a16:creationId xmlns:a16="http://schemas.microsoft.com/office/drawing/2014/main" id="{5CEABC25-161C-3F6F-F328-4E482CB3E248}"/>
+              </a:ext>
+            </a:extLst>
+          </p:cNvPr>
+          <p:cNvPicPr>
+            <a:picLocks noChangeAspect="1"/>
+          </p:cNvPicPr>
+          <p:nvPr/>
+        </p:nvPicPr>
+        <p:blipFill>
+          <a:blip r:embed="rId2"/>
+          <a:stretch>
+            <a:fillRect/>
+          </a:stretch>
+        </p:blipFill>
+        <p:spPr>
+          <a:xfrm>
+            <a:off x="270649" y="799733"/>
+            <a:ext cx="11650701" cy="5258534"/>
+          </a:xfrm>
+          <a:prstGeom prst="rect">
+            <a:avLst/>
+          </a:prstGeom>
+        </p:spPr>
+      </p:pic>
+      <p:sp>
+        <p:nvSpPr>
+          <p:cNvPr id="5" name="Rectangle: Rounded Corners 4">
+            <a:extLst>
+              <a:ext uri="{FF2B5EF4-FFF2-40B4-BE49-F238E27FC236}">
+                <a16:creationId xmlns:a16="http://schemas.microsoft.com/office/drawing/2014/main" id="{4BCB5966-3ADC-0928-B62B-15B23DAF1DFB}"/>
+              </a:ext>
+            </a:extLst>
+          </p:cNvPr>
+          <p:cNvSpPr/>
+          <p:nvPr/>
+        </p:nvSpPr>
+        <p:spPr>
+          <a:xfrm>
+            <a:off x="6445956" y="3522767"/>
+            <a:ext cx="1365953" cy="336039"/>
+          </a:xfrm>
+          <a:prstGeom prst="roundRect">
+            <a:avLst/>
+          </a:prstGeom>
+          <a:noFill/>
+          <a:ln w="25400">
+            <a:solidFill>
+              <a:srgbClr val="C00000"/>
+            </a:solidFill>
+          </a:ln>
+          <a:effectLst>
+            <a:outerShdw blurRad="50800" dist="38100" dir="2700000" algn="tl" rotWithShape="0">
+              <a:prstClr val="black">
+                <a:alpha val="40000"/>
+              </a:prstClr>
+            </a:outerShdw>
+          </a:effectLst>
+        </p:spPr>
+        <p:style>
+          <a:lnRef idx="2">
+            <a:schemeClr val="accent1">
+              <a:shade val="15000"/>
+            </a:schemeClr>
+          </a:lnRef>
+          <a:fillRef idx="1">
+            <a:schemeClr val="accent1"/>
+          </a:fillRef>
+          <a:effectRef idx="0">
+            <a:schemeClr val="accent1"/>
+          </a:effectRef>
+          <a:fontRef idx="minor">
+            <a:schemeClr val="lt1"/>
+          </a:fontRef>
+        </p:style>
+        <p:txBody>
+          <a:bodyPr rtlCol="0" anchor="ctr"/>
+          <a:lstStyle/>
+          <a:p>
+            <a:pPr algn="ctr"/>
+            <a:endParaRPr lang="en-GB"/>
+          </a:p>
+        </p:txBody>
+      </p:sp>
+      <p:sp>
+        <p:nvSpPr>
+          <p:cNvPr id="6" name="Arrow: Right 5">
+            <a:extLst>
+              <a:ext uri="{FF2B5EF4-FFF2-40B4-BE49-F238E27FC236}">
+                <a16:creationId xmlns:a16="http://schemas.microsoft.com/office/drawing/2014/main" id="{1B6D0555-0738-0B46-7EFC-98D7E63E66B4}"/>
+              </a:ext>
+            </a:extLst>
+          </p:cNvPr>
+          <p:cNvSpPr/>
+          <p:nvPr/>
+        </p:nvSpPr>
+        <p:spPr>
+          <a:xfrm rot="8441955">
+            <a:off x="7748216" y="2994364"/>
+            <a:ext cx="978408" cy="334025"/>
+          </a:xfrm>
+          <a:prstGeom prst="rightArrow">
+            <a:avLst/>
+          </a:prstGeom>
+          <a:solidFill>
+            <a:srgbClr val="C00000"/>
+          </a:solidFill>
+          <a:ln>
+            <a:noFill/>
+          </a:ln>
+          <a:effectLst>
+            <a:outerShdw blurRad="50800" dist="38100" dir="2700000" algn="tl" rotWithShape="0">
+              <a:prstClr val="black">
+                <a:alpha val="40000"/>
+              </a:prstClr>
+            </a:outerShdw>
+          </a:effectLst>
+        </p:spPr>
+        <p:style>
+          <a:lnRef idx="2">
+            <a:schemeClr val="accent1">
+              <a:shade val="15000"/>
+            </a:schemeClr>
+          </a:lnRef>
+          <a:fillRef idx="1">
+            <a:schemeClr val="accent1"/>
+          </a:fillRef>
+          <a:effectRef idx="0">
+            <a:schemeClr val="accent1"/>
+          </a:effectRef>
+          <a:fontRef idx="minor">
+            <a:schemeClr val="lt1"/>
+          </a:fontRef>
+        </p:style>
+        <p:txBody>
+          <a:bodyPr rtlCol="0" anchor="ctr"/>
+          <a:lstStyle/>
+          <a:p>
+            <a:pPr algn="ctr"/>
+            <a:endParaRPr lang="en-GB"/>
+          </a:p>
+        </p:txBody>
+      </p:sp>
+    </p:spTree>
+    <p:extLst>
+      <p:ext uri="{BB962C8B-B14F-4D97-AF65-F5344CB8AC3E}">
+        <p14:creationId xmlns:p14="http://schemas.microsoft.com/office/powerpoint/2010/main" val="3504887386"/>
+      </p:ext>
+    </p:extLst>
+  </p:cSld>
+  <p:clrMapOvr>
+    <a:masterClrMapping/>
+  </p:clrMapOvr>
+</p:sld>
+</file>
+
 <file path=ppt/theme/theme1.xml><?xml version="1.0" encoding="utf-8"?>
 <a:theme xmlns:a="http://schemas.openxmlformats.org/drawingml/2006/main" name="Office Theme">
   <a:themeElements>

</xml_diff>